<commit_message>
changes to powerpoint creation
</commit_message>
<xml_diff>
--- a/src/main/resources/template.pptx
+++ b/src/main/resources/template.pptx
@@ -5,18 +5,19 @@
     <p:sldMasterId id="2147483648" r:id="rId4"/>
   </p:sldMasterIdLst>
   <p:notesMasterIdLst>
-    <p:notesMasterId r:id="rId6"/>
+    <p:notesMasterId r:id="rId7"/>
   </p:notesMasterIdLst>
   <p:handoutMasterIdLst>
-    <p:handoutMasterId r:id="rId7"/>
+    <p:handoutMasterId r:id="rId8"/>
   </p:handoutMasterIdLst>
   <p:sldIdLst>
-    <p:sldId id="276" r:id="rId5"/>
+    <p:sldId id="277" r:id="rId5"/>
+    <p:sldId id="278" r:id="rId6"/>
   </p:sldIdLst>
   <p:sldSz cx="12192000" cy="6858000"/>
   <p:notesSz cx="6858000" cy="9144000"/>
   <p:custDataLst>
-    <p:tags r:id="rId8"/>
+    <p:tags r:id="rId9"/>
   </p:custDataLst>
   <p:defaultTextStyle>
     <a:defPPr>
@@ -254,7 +255,7 @@
           <a:p>
             <a:fld id="{C3440642-083C-45F1-96AE-6C40D1428CD6}" type="datetimeFigureOut">
               <a:rPr lang="en-GB" smtClean="0"/>
-              <a:t>15/02/2025</a:t>
+              <a:t>20/02/2025</a:t>
             </a:fld>
             <a:endParaRPr lang="en-GB"/>
           </a:p>
@@ -431,7 +432,7 @@
           <a:p>
             <a:fld id="{DEE2F1A5-1147-44AA-941C-401C9E3002E6}" type="datetimeFigureOut">
               <a:rPr lang="en-US" smtClean="0"/>
-              <a:t>2/15/2025</a:t>
+              <a:t>2/20/2025</a:t>
             </a:fld>
             <a:endParaRPr lang="en-US"/>
           </a:p>
@@ -698,90 +699,6 @@
 </p:notesMaster>
 </file>
 
-<file path=ppt/notesSlides/notesSlide1.xml><?xml version="1.0" encoding="utf-8"?>
-<p:notes xmlns:a="http://schemas.openxmlformats.org/drawingml/2006/main" xmlns:r="http://schemas.openxmlformats.org/officeDocument/2006/relationships" xmlns:p="http://schemas.openxmlformats.org/presentationml/2006/main">
-  <p:cSld>
-    <p:spTree>
-      <p:nvGrpSpPr>
-        <p:cNvPr id="1" name=""/>
-        <p:cNvGrpSpPr/>
-        <p:nvPr/>
-      </p:nvGrpSpPr>
-      <p:grpSpPr>
-        <a:xfrm>
-          <a:off x="0" y="0"/>
-          <a:ext cx="0" cy="0"/>
-          <a:chOff x="0" y="0"/>
-          <a:chExt cx="0" cy="0"/>
-        </a:xfrm>
-      </p:grpSpPr>
-      <p:sp>
-        <p:nvSpPr>
-          <p:cNvPr id="2" name="Slide Image Placeholder 1"/>
-          <p:cNvSpPr>
-            <a:spLocks noGrp="1" noRot="1" noChangeAspect="1"/>
-          </p:cNvSpPr>
-          <p:nvPr>
-            <p:ph type="sldImg"/>
-          </p:nvPr>
-        </p:nvSpPr>
-        <p:spPr/>
-      </p:sp>
-      <p:sp>
-        <p:nvSpPr>
-          <p:cNvPr id="3" name="Notes Placeholder 2"/>
-          <p:cNvSpPr>
-            <a:spLocks noGrp="1"/>
-          </p:cNvSpPr>
-          <p:nvPr>
-            <p:ph type="body" idx="1"/>
-          </p:nvPr>
-        </p:nvSpPr>
-        <p:spPr/>
-        <p:txBody>
-          <a:bodyPr/>
-          <a:lstStyle/>
-          <a:p>
-            <a:endParaRPr lang="en-DE"/>
-          </a:p>
-        </p:txBody>
-      </p:sp>
-      <p:sp>
-        <p:nvSpPr>
-          <p:cNvPr id="4" name="Slide Number Placeholder 3"/>
-          <p:cNvSpPr>
-            <a:spLocks noGrp="1"/>
-          </p:cNvSpPr>
-          <p:nvPr>
-            <p:ph type="sldNum" sz="quarter" idx="5"/>
-          </p:nvPr>
-        </p:nvSpPr>
-        <p:spPr/>
-        <p:txBody>
-          <a:bodyPr/>
-          <a:lstStyle/>
-          <a:p>
-            <a:fld id="{4AF3249D-E364-4AF9-8113-7FC01C784AA7}" type="slidenum">
-              <a:rPr lang="en-US" smtClean="0"/>
-              <a:t>1</a:t>
-            </a:fld>
-            <a:endParaRPr lang="en-US"/>
-          </a:p>
-        </p:txBody>
-      </p:sp>
-    </p:spTree>
-    <p:extLst>
-      <p:ext uri="{BB962C8B-B14F-4D97-AF65-F5344CB8AC3E}">
-        <p14:creationId xmlns:p14="http://schemas.microsoft.com/office/powerpoint/2010/main" val="3682636401"/>
-      </p:ext>
-    </p:extLst>
-  </p:cSld>
-  <p:clrMapOvr>
-    <a:masterClrMapping/>
-  </p:clrMapOvr>
-</p:notes>
-</file>
-
 <file path=ppt/slideLayouts/slideLayout1.xml><?xml version="1.0" encoding="utf-8"?>
 <p:sldLayout xmlns:a="http://schemas.openxmlformats.org/drawingml/2006/main" xmlns:r="http://schemas.openxmlformats.org/officeDocument/2006/relationships" xmlns:p="http://schemas.openxmlformats.org/presentationml/2006/main" preserve="1" userDrawn="1">
   <p:cSld name="MLReply [ENG]">
@@ -1151,7 +1068,7 @@
               </a:spcBef>
             </a:pPr>
             <a:r>
-              <a:rPr lang="en-US"/>
+              <a:rPr lang="en-US" dirty="0"/>
               <a:t>Description for a project – Position</a:t>
             </a:r>
           </a:p>
@@ -1162,7 +1079,7 @@
               </a:spcBef>
             </a:pPr>
             <a:r>
-              <a:rPr lang="en-US" sz="900"/>
+              <a:rPr lang="en-US" sz="900" dirty="0"/>
               <a:t>Item</a:t>
             </a:r>
           </a:p>
@@ -1173,10 +1090,10 @@
               </a:spcBef>
             </a:pPr>
             <a:r>
-              <a:rPr lang="en-US" sz="900"/>
+              <a:rPr lang="en-US" sz="900" dirty="0"/>
               <a:t>Item</a:t>
             </a:r>
-            <a:endParaRPr lang="de-DE"/>
+            <a:endParaRPr lang="de-DE" dirty="0"/>
           </a:p>
         </p:txBody>
       </p:sp>
@@ -4533,7 +4450,7 @@
           <a:lstStyle/>
           <a:p>
             <a:r>
-              <a:rPr lang="en-US" sz="2800" b="1" spc="100" baseline="0">
+              <a:rPr lang="en-US" sz="2800" b="1" spc="100" baseline="0" dirty="0">
                 <a:solidFill>
                   <a:srgbClr val="00444C"/>
                 </a:solidFill>
@@ -4541,7 +4458,7 @@
               </a:rPr>
               <a:t>SHORT SUMMARY AND PROJECT EXPERIENCE</a:t>
             </a:r>
-            <a:endParaRPr lang="de-DE" sz="2800" b="1" spc="100" baseline="0">
+            <a:endParaRPr lang="de-DE" sz="2800" b="1" spc="100" baseline="0" dirty="0">
               <a:solidFill>
                 <a:srgbClr val="00444C"/>
               </a:solidFill>
@@ -4588,47 +4505,7 @@
       </p:pic>
       <p:sp>
         <p:nvSpPr>
-          <p:cNvPr id="28" name="Picture Placeholder 9">
-            <a:extLst>
-              <a:ext uri="{FF2B5EF4-FFF2-40B4-BE49-F238E27FC236}">
-                <a16:creationId xmlns:a16="http://schemas.microsoft.com/office/drawing/2014/main" id="{70E6DDC3-1D04-E1B4-D33B-A66B1DDB7EBE}"/>
-              </a:ext>
-            </a:extLst>
-          </p:cNvPr>
-          <p:cNvSpPr>
-            <a:spLocks noGrp="1"/>
-          </p:cNvSpPr>
-          <p:nvPr>
-            <p:ph type="pic" sz="quarter" idx="18" hasCustomPrompt="1"/>
-          </p:nvPr>
-        </p:nvSpPr>
-        <p:spPr>
-          <a:xfrm>
-            <a:off x="447675" y="1366838"/>
-            <a:ext cx="1147763" cy="1457325"/>
-          </a:xfrm>
-          <a:prstGeom prst="rect">
-            <a:avLst/>
-          </a:prstGeom>
-        </p:spPr>
-        <p:txBody>
-          <a:bodyPr/>
-          <a:lstStyle>
-            <a:lvl1pPr>
-              <a:defRPr b="0" i="1" u="none"/>
-            </a:lvl1pPr>
-          </a:lstStyle>
-          <a:p>
-            <a:r>
-              <a:rPr lang="de-DE"/>
-              <a:t>Picture</a:t>
-            </a:r>
-          </a:p>
-        </p:txBody>
-      </p:sp>
-      <p:sp>
-        <p:nvSpPr>
-          <p:cNvPr id="33" name="Text Placeholder 11">
+          <p:cNvPr id="33" name="RoleText">
             <a:extLst>
               <a:ext uri="{FF2B5EF4-FFF2-40B4-BE49-F238E27FC236}">
                 <a16:creationId xmlns:a16="http://schemas.microsoft.com/office/drawing/2014/main" id="{7262B094-0E69-5839-C08D-46579E0EDB95}"/>
@@ -4821,7 +4698,7 @@
       </p:sp>
       <p:sp>
         <p:nvSpPr>
-          <p:cNvPr id="24" name="Text Placeholder 11">
+          <p:cNvPr id="24" name="NameText">
             <a:extLst>
               <a:ext uri="{FF2B5EF4-FFF2-40B4-BE49-F238E27FC236}">
                 <a16:creationId xmlns:a16="http://schemas.microsoft.com/office/drawing/2014/main" id="{F0FE5748-2E7E-E6A6-6A28-D26B4D5C1D6A}"/>
@@ -4876,7 +4753,7 @@
       </p:sp>
       <p:sp>
         <p:nvSpPr>
-          <p:cNvPr id="29" name="Text Placeholder 11">
+          <p:cNvPr id="29" name="phoneText">
             <a:extLst>
               <a:ext uri="{FF2B5EF4-FFF2-40B4-BE49-F238E27FC236}">
                 <a16:creationId xmlns:a16="http://schemas.microsoft.com/office/drawing/2014/main" id="{32D758A8-5F1A-0074-1212-0D202F54F6B7}"/>
@@ -4930,7 +4807,7 @@
       </p:sp>
       <p:sp>
         <p:nvSpPr>
-          <p:cNvPr id="30" name="Text Placeholder 11">
+          <p:cNvPr id="30" name="emailText">
             <a:extLst>
               <a:ext uri="{FF2B5EF4-FFF2-40B4-BE49-F238E27FC236}">
                 <a16:creationId xmlns:a16="http://schemas.microsoft.com/office/drawing/2014/main" id="{D22EA4D4-086D-609B-9F4E-D76622CA1133}"/>
@@ -5186,7 +5063,7 @@
       </p:sp>
       <p:sp>
         <p:nvSpPr>
-          <p:cNvPr id="31" name="Text Placeholder 5">
+          <p:cNvPr id="31" name="ProfessionalBackgroundText">
             <a:extLst>
               <a:ext uri="{FF2B5EF4-FFF2-40B4-BE49-F238E27FC236}">
                 <a16:creationId xmlns:a16="http://schemas.microsoft.com/office/drawing/2014/main" id="{4FCCEF2F-5422-5F45-AFBA-83996B2FEDC1}"/>
@@ -5260,7 +5137,7 @@
       </p:sp>
       <p:sp>
         <p:nvSpPr>
-          <p:cNvPr id="46" name="Text Placeholder 5">
+          <p:cNvPr id="46" name="IndustryExpertiseText">
             <a:extLst>
               <a:ext uri="{FF2B5EF4-FFF2-40B4-BE49-F238E27FC236}">
                 <a16:creationId xmlns:a16="http://schemas.microsoft.com/office/drawing/2014/main" id="{8BEDB43C-CCA4-564E-805F-6F1A39F1A537}"/>
@@ -5380,7 +5257,7 @@
       </p:sp>
       <p:sp>
         <p:nvSpPr>
-          <p:cNvPr id="47" name="Text Placeholder 5">
+          <p:cNvPr id="47" name="FunctionExpertiseText">
             <a:extLst>
               <a:ext uri="{FF2B5EF4-FFF2-40B4-BE49-F238E27FC236}">
                 <a16:creationId xmlns:a16="http://schemas.microsoft.com/office/drawing/2014/main" id="{B49D48AB-DE9D-2846-9D63-92B5B328CE03}"/>
@@ -5484,7 +5361,7 @@
       </p:sp>
       <p:sp>
         <p:nvSpPr>
-          <p:cNvPr id="35" name="Text Placeholder 5">
+          <p:cNvPr id="35" name="ProjectText">
             <a:extLst>
               <a:ext uri="{FF2B5EF4-FFF2-40B4-BE49-F238E27FC236}">
                 <a16:creationId xmlns:a16="http://schemas.microsoft.com/office/drawing/2014/main" id="{6FB59864-C817-1941-85A9-0863DE51ADDF}"/>
@@ -5584,6 +5461,46 @@
               <a:t>Item</a:t>
             </a:r>
             <a:endParaRPr lang="de-DE"/>
+          </a:p>
+        </p:txBody>
+      </p:sp>
+      <p:sp>
+        <p:nvSpPr>
+          <p:cNvPr id="6" name="ProfilePicture">
+            <a:extLst>
+              <a:ext uri="{FF2B5EF4-FFF2-40B4-BE49-F238E27FC236}">
+                <a16:creationId xmlns:a16="http://schemas.microsoft.com/office/drawing/2014/main" id="{90725F5E-284F-61FA-0C96-43866E3B1005}"/>
+              </a:ext>
+            </a:extLst>
+          </p:cNvPr>
+          <p:cNvSpPr>
+            <a:spLocks noGrp="1"/>
+          </p:cNvSpPr>
+          <p:nvPr>
+            <p:ph type="pic" sz="quarter" idx="18" hasCustomPrompt="1"/>
+          </p:nvPr>
+        </p:nvSpPr>
+        <p:spPr>
+          <a:xfrm>
+            <a:off x="447675" y="1366838"/>
+            <a:ext cx="1147763" cy="1457325"/>
+          </a:xfrm>
+          <a:prstGeom prst="rect">
+            <a:avLst/>
+          </a:prstGeom>
+        </p:spPr>
+        <p:txBody>
+          <a:bodyPr/>
+          <a:lstStyle>
+            <a:lvl1pPr>
+              <a:defRPr b="0" i="1" u="none"/>
+            </a:lvl1pPr>
+          </a:lstStyle>
+          <a:p>
+            <a:r>
+              <a:rPr lang="de-DE"/>
+              <a:t>Picture</a:t>
+            </a:r>
           </a:p>
         </p:txBody>
       </p:sp>
@@ -6138,47 +6055,7 @@
       </p:pic>
       <p:sp>
         <p:nvSpPr>
-          <p:cNvPr id="28" name="Picture Placeholder 9">
-            <a:extLst>
-              <a:ext uri="{FF2B5EF4-FFF2-40B4-BE49-F238E27FC236}">
-                <a16:creationId xmlns:a16="http://schemas.microsoft.com/office/drawing/2014/main" id="{70E6DDC3-1D04-E1B4-D33B-A66B1DDB7EBE}"/>
-              </a:ext>
-            </a:extLst>
-          </p:cNvPr>
-          <p:cNvSpPr>
-            <a:spLocks noGrp="1"/>
-          </p:cNvSpPr>
-          <p:nvPr>
-            <p:ph type="pic" sz="quarter" idx="18" hasCustomPrompt="1"/>
-          </p:nvPr>
-        </p:nvSpPr>
-        <p:spPr>
-          <a:xfrm>
-            <a:off x="447675" y="1366838"/>
-            <a:ext cx="1147763" cy="1457325"/>
-          </a:xfrm>
-          <a:prstGeom prst="rect">
-            <a:avLst/>
-          </a:prstGeom>
-        </p:spPr>
-        <p:txBody>
-          <a:bodyPr/>
-          <a:lstStyle>
-            <a:lvl1pPr>
-              <a:defRPr b="0" i="1" u="none"/>
-            </a:lvl1pPr>
-          </a:lstStyle>
-          <a:p>
-            <a:r>
-              <a:rPr lang="de-DE"/>
-              <a:t>Picture</a:t>
-            </a:r>
-          </a:p>
-        </p:txBody>
-      </p:sp>
-      <p:sp>
-        <p:nvSpPr>
-          <p:cNvPr id="31" name="Text Placeholder 11">
+          <p:cNvPr id="31" name="NameText">
             <a:extLst>
               <a:ext uri="{FF2B5EF4-FFF2-40B4-BE49-F238E27FC236}">
                 <a16:creationId xmlns:a16="http://schemas.microsoft.com/office/drawing/2014/main" id="{7CF0ECDA-F061-0A99-CED3-8F332A38604F}"/>
@@ -6233,7 +6110,7 @@
       </p:sp>
       <p:sp>
         <p:nvSpPr>
-          <p:cNvPr id="33" name="Text Placeholder 11">
+          <p:cNvPr id="33" name="RoleText">
             <a:extLst>
               <a:ext uri="{FF2B5EF4-FFF2-40B4-BE49-F238E27FC236}">
                 <a16:creationId xmlns:a16="http://schemas.microsoft.com/office/drawing/2014/main" id="{7262B094-0E69-5839-C08D-46579E0EDB95}"/>
@@ -6426,7 +6303,7 @@
       </p:sp>
       <p:sp>
         <p:nvSpPr>
-          <p:cNvPr id="25" name="Text Placeholder 11">
+          <p:cNvPr id="25" name="phoneText">
             <a:extLst>
               <a:ext uri="{FF2B5EF4-FFF2-40B4-BE49-F238E27FC236}">
                 <a16:creationId xmlns:a16="http://schemas.microsoft.com/office/drawing/2014/main" id="{AF4F0D18-D54E-AA5B-7B30-77AC84F934E2}"/>
@@ -6480,7 +6357,7 @@
       </p:sp>
       <p:sp>
         <p:nvSpPr>
-          <p:cNvPr id="26" name="Text Placeholder 11">
+          <p:cNvPr id="26" name="emailText">
             <a:extLst>
               <a:ext uri="{FF2B5EF4-FFF2-40B4-BE49-F238E27FC236}">
                 <a16:creationId xmlns:a16="http://schemas.microsoft.com/office/drawing/2014/main" id="{0E86E825-4327-29EF-D6BD-E469CD46C7A3}"/>
@@ -6736,7 +6613,7 @@
       </p:sp>
       <p:sp>
         <p:nvSpPr>
-          <p:cNvPr id="30" name="Text Placeholder 5">
+          <p:cNvPr id="30" name="ProfessionalBackgroundText">
             <a:extLst>
               <a:ext uri="{FF2B5EF4-FFF2-40B4-BE49-F238E27FC236}">
                 <a16:creationId xmlns:a16="http://schemas.microsoft.com/office/drawing/2014/main" id="{A62AEF2E-8175-0541-B8B5-1F181740274A}"/>
@@ -6802,7 +6679,7 @@
           <a:p>
             <a:pPr lvl="0"/>
             <a:r>
-              <a:rPr lang="en-US"/>
+              <a:rPr lang="en-US" dirty="0"/>
               <a:t>Text in paragraphs with relevant information highlighted in bold.</a:t>
             </a:r>
           </a:p>
@@ -6810,7 +6687,7 @@
       </p:sp>
       <p:sp>
         <p:nvSpPr>
-          <p:cNvPr id="47" name="Text Placeholder 5">
+          <p:cNvPr id="47" name="IndustryExpertiseText">
             <a:extLst>
               <a:ext uri="{FF2B5EF4-FFF2-40B4-BE49-F238E27FC236}">
                 <a16:creationId xmlns:a16="http://schemas.microsoft.com/office/drawing/2014/main" id="{95081835-8E6F-A046-AFC3-C8FE583B8D49}"/>
@@ -6930,7 +6807,7 @@
       </p:sp>
       <p:sp>
         <p:nvSpPr>
-          <p:cNvPr id="50" name="Text Placeholder 5">
+          <p:cNvPr id="50" name="FunctionExpertiseText">
             <a:extLst>
               <a:ext uri="{FF2B5EF4-FFF2-40B4-BE49-F238E27FC236}">
                 <a16:creationId xmlns:a16="http://schemas.microsoft.com/office/drawing/2014/main" id="{BF858FE2-50E4-7D42-A47B-FBF8A73CEF8A}"/>
@@ -7034,7 +6911,7 @@
       </p:sp>
       <p:sp>
         <p:nvSpPr>
-          <p:cNvPr id="34" name="Text Placeholder 5">
+          <p:cNvPr id="34" name="ProjectText">
             <a:extLst>
               <a:ext uri="{FF2B5EF4-FFF2-40B4-BE49-F238E27FC236}">
                 <a16:creationId xmlns:a16="http://schemas.microsoft.com/office/drawing/2014/main" id="{F2FE85A1-8AE6-E443-9E91-74C7EFE70E15}"/>
@@ -7134,6 +7011,46 @@
               <a:t>Item</a:t>
             </a:r>
             <a:endParaRPr lang="de-DE"/>
+          </a:p>
+        </p:txBody>
+      </p:sp>
+      <p:sp>
+        <p:nvSpPr>
+          <p:cNvPr id="5" name="ProfilePicture">
+            <a:extLst>
+              <a:ext uri="{FF2B5EF4-FFF2-40B4-BE49-F238E27FC236}">
+                <a16:creationId xmlns:a16="http://schemas.microsoft.com/office/drawing/2014/main" id="{312DC305-6F6C-AE8F-4090-85EDEC77480C}"/>
+              </a:ext>
+            </a:extLst>
+          </p:cNvPr>
+          <p:cNvSpPr>
+            <a:spLocks noGrp="1"/>
+          </p:cNvSpPr>
+          <p:nvPr>
+            <p:ph type="pic" sz="quarter" idx="18" hasCustomPrompt="1"/>
+          </p:nvPr>
+        </p:nvSpPr>
+        <p:spPr>
+          <a:xfrm>
+            <a:off x="447675" y="1366838"/>
+            <a:ext cx="1147763" cy="1457325"/>
+          </a:xfrm>
+          <a:prstGeom prst="rect">
+            <a:avLst/>
+          </a:prstGeom>
+        </p:spPr>
+        <p:txBody>
+          <a:bodyPr/>
+          <a:lstStyle>
+            <a:lvl1pPr>
+              <a:defRPr b="0" i="1" u="none"/>
+            </a:lvl1pPr>
+          </a:lstStyle>
+          <a:p>
+            <a:r>
+              <a:rPr lang="de-DE"/>
+              <a:t>Picture</a:t>
+            </a:r>
           </a:p>
         </p:txBody>
       </p:sp>
@@ -7711,10 +7628,249 @@
       </p:grpSpPr>
       <p:sp>
         <p:nvSpPr>
-          <p:cNvPr id="12" name="ProjectText">
-            <a:extLst>
-              <a:ext uri="{FF2B5EF4-FFF2-40B4-BE49-F238E27FC236}">
-                <a16:creationId xmlns:a16="http://schemas.microsoft.com/office/drawing/2014/main" id="{BEF1888E-6A0F-4840-9F30-1A22BD4B3351}"/>
+          <p:cNvPr id="2" name="RoleText">
+            <a:extLst>
+              <a:ext uri="{FF2B5EF4-FFF2-40B4-BE49-F238E27FC236}">
+                <a16:creationId xmlns:a16="http://schemas.microsoft.com/office/drawing/2014/main" id="{ECB340C3-4D23-9BA0-09FC-B934FA527477}"/>
+              </a:ext>
+            </a:extLst>
+          </p:cNvPr>
+          <p:cNvSpPr>
+            <a:spLocks noGrp="1"/>
+          </p:cNvSpPr>
+          <p:nvPr>
+            <p:ph type="body" sz="quarter" idx="20"/>
+          </p:nvPr>
+        </p:nvSpPr>
+        <p:spPr/>
+        <p:txBody>
+          <a:bodyPr/>
+          <a:lstStyle/>
+          <a:p>
+            <a:r>
+              <a:rPr lang="de-DE" dirty="0"/>
+              <a:t>Lala</a:t>
+            </a:r>
+          </a:p>
+        </p:txBody>
+      </p:sp>
+      <p:sp>
+        <p:nvSpPr>
+          <p:cNvPr id="3" name="NameText">
+            <a:extLst>
+              <a:ext uri="{FF2B5EF4-FFF2-40B4-BE49-F238E27FC236}">
+                <a16:creationId xmlns:a16="http://schemas.microsoft.com/office/drawing/2014/main" id="{BC23F51A-8CFE-717A-1D38-947B029006F9}"/>
+              </a:ext>
+            </a:extLst>
+          </p:cNvPr>
+          <p:cNvSpPr>
+            <a:spLocks noGrp="1"/>
+          </p:cNvSpPr>
+          <p:nvPr>
+            <p:ph type="body" sz="quarter" idx="19"/>
+          </p:nvPr>
+        </p:nvSpPr>
+        <p:spPr/>
+        <p:txBody>
+          <a:bodyPr/>
+          <a:lstStyle/>
+          <a:p>
+            <a:r>
+              <a:rPr lang="de-DE" dirty="0"/>
+              <a:t>Maurits</a:t>
+            </a:r>
+          </a:p>
+        </p:txBody>
+      </p:sp>
+      <p:sp>
+        <p:nvSpPr>
+          <p:cNvPr id="4" name="phoneText">
+            <a:extLst>
+              <a:ext uri="{FF2B5EF4-FFF2-40B4-BE49-F238E27FC236}">
+                <a16:creationId xmlns:a16="http://schemas.microsoft.com/office/drawing/2014/main" id="{AA42BBD9-F2A8-C8AF-B629-695D8813BF3C}"/>
+              </a:ext>
+            </a:extLst>
+          </p:cNvPr>
+          <p:cNvSpPr>
+            <a:spLocks noGrp="1"/>
+          </p:cNvSpPr>
+          <p:nvPr>
+            <p:ph type="body" sz="quarter" idx="23"/>
+          </p:nvPr>
+        </p:nvSpPr>
+        <p:spPr/>
+        <p:txBody>
+          <a:bodyPr/>
+          <a:lstStyle/>
+          <a:p>
+            <a:r>
+              <a:rPr lang="de-DE" dirty="0"/>
+              <a:t>na</a:t>
+            </a:r>
+          </a:p>
+        </p:txBody>
+      </p:sp>
+      <p:sp>
+        <p:nvSpPr>
+          <p:cNvPr id="5" name="emailText">
+            <a:extLst>
+              <a:ext uri="{FF2B5EF4-FFF2-40B4-BE49-F238E27FC236}">
+                <a16:creationId xmlns:a16="http://schemas.microsoft.com/office/drawing/2014/main" id="{45001E35-BF80-7FA3-BCDB-7D05BC0EA97A}"/>
+              </a:ext>
+            </a:extLst>
+          </p:cNvPr>
+          <p:cNvSpPr>
+            <a:spLocks noGrp="1"/>
+          </p:cNvSpPr>
+          <p:nvPr>
+            <p:ph type="body" sz="quarter" idx="24"/>
+          </p:nvPr>
+        </p:nvSpPr>
+        <p:spPr/>
+        <p:txBody>
+          <a:bodyPr/>
+          <a:lstStyle/>
+          <a:p>
+            <a:r>
+              <a:rPr lang="de-DE" dirty="0"/>
+              <a:t>na</a:t>
+            </a:r>
+          </a:p>
+        </p:txBody>
+      </p:sp>
+      <p:sp>
+        <p:nvSpPr>
+          <p:cNvPr id="6" name="Text Placeholder 5">
+            <a:extLst>
+              <a:ext uri="{FF2B5EF4-FFF2-40B4-BE49-F238E27FC236}">
+                <a16:creationId xmlns:a16="http://schemas.microsoft.com/office/drawing/2014/main" id="{114F3B20-D5C5-61E5-A735-45BADE0D45CA}"/>
+              </a:ext>
+            </a:extLst>
+          </p:cNvPr>
+          <p:cNvSpPr>
+            <a:spLocks noGrp="1"/>
+          </p:cNvSpPr>
+          <p:nvPr>
+            <p:ph type="body" sz="quarter" idx="26"/>
+          </p:nvPr>
+        </p:nvSpPr>
+        <p:spPr/>
+        <p:txBody>
+          <a:bodyPr/>
+          <a:lstStyle/>
+          <a:p>
+            <a:endParaRPr lang="de-DE"/>
+          </a:p>
+        </p:txBody>
+      </p:sp>
+      <p:sp>
+        <p:nvSpPr>
+          <p:cNvPr id="7" name="ProfessionalBackgroundText">
+            <a:extLst>
+              <a:ext uri="{FF2B5EF4-FFF2-40B4-BE49-F238E27FC236}">
+                <a16:creationId xmlns:a16="http://schemas.microsoft.com/office/drawing/2014/main" id="{BE7DE9D6-56A3-4620-C0CE-6D16FA8973F3}"/>
+              </a:ext>
+            </a:extLst>
+          </p:cNvPr>
+          <p:cNvSpPr>
+            <a:spLocks noGrp="1"/>
+          </p:cNvSpPr>
+          <p:nvPr>
+            <p:ph type="body" sz="quarter" idx="25"/>
+          </p:nvPr>
+        </p:nvSpPr>
+        <p:spPr/>
+        <p:txBody>
+          <a:bodyPr/>
+          <a:lstStyle/>
+          <a:p>
+            <a:r>
+              <a:rPr lang="de-DE" dirty="0"/>
+              <a:t>SomeText</a:t>
+            </a:r>
+          </a:p>
+        </p:txBody>
+      </p:sp>
+      <p:sp>
+        <p:nvSpPr>
+          <p:cNvPr id="8" name="IndustryExpertiseText">
+            <a:extLst>
+              <a:ext uri="{FF2B5EF4-FFF2-40B4-BE49-F238E27FC236}">
+                <a16:creationId xmlns:a16="http://schemas.microsoft.com/office/drawing/2014/main" id="{7B1DC21B-3EC1-23E4-B4BC-C72E7490D6F3}"/>
+              </a:ext>
+            </a:extLst>
+          </p:cNvPr>
+          <p:cNvSpPr>
+            <a:spLocks noGrp="1"/>
+          </p:cNvSpPr>
+          <p:nvPr>
+            <p:ph type="body" sz="quarter" idx="17"/>
+          </p:nvPr>
+        </p:nvSpPr>
+        <p:spPr/>
+        <p:txBody>
+          <a:bodyPr/>
+          <a:lstStyle/>
+          <a:p>
+            <a:r>
+              <a:rPr lang="de-DE" dirty="0"/>
+              <a:t>Knowledge Graphs (Neo4j, Socially Linked Data, RDF, OWL)</a:t>
+            </a:r>
+          </a:p>
+          <a:p>
+            <a:r>
+              <a:rPr lang="de-DE" dirty="0"/>
+              <a:t>Software Engineering (Open API, Java, JavaScript, Python, Rust)</a:t>
+            </a:r>
+          </a:p>
+          <a:p>
+            <a:endParaRPr lang="de-DE" dirty="0"/>
+          </a:p>
+        </p:txBody>
+      </p:sp>
+      <p:sp>
+        <p:nvSpPr>
+          <p:cNvPr id="9" name="FunctionExpertiseText">
+            <a:extLst>
+              <a:ext uri="{FF2B5EF4-FFF2-40B4-BE49-F238E27FC236}">
+                <a16:creationId xmlns:a16="http://schemas.microsoft.com/office/drawing/2014/main" id="{D719B103-2DE4-AE54-A9BC-E299EF0580E2}"/>
+              </a:ext>
+            </a:extLst>
+          </p:cNvPr>
+          <p:cNvSpPr>
+            <a:spLocks noGrp="1"/>
+          </p:cNvSpPr>
+          <p:nvPr>
+            <p:ph type="body" sz="quarter" idx="11"/>
+          </p:nvPr>
+        </p:nvSpPr>
+        <p:spPr/>
+        <p:txBody>
+          <a:bodyPr/>
+          <a:lstStyle/>
+          <a:p>
+            <a:r>
+              <a:rPr lang="de-DE" dirty="0"/>
+              <a:t>Knowledge Graphs (Neo4j, Socially Linked Data, RDF, OWL)</a:t>
+            </a:r>
+          </a:p>
+          <a:p>
+            <a:r>
+              <a:rPr lang="de-DE" dirty="0"/>
+              <a:t>Software Engineering (Open API, Java, JavaScript, Python, Rust)</a:t>
+            </a:r>
+          </a:p>
+          <a:p>
+            <a:endParaRPr lang="de-DE" dirty="0"/>
+          </a:p>
+        </p:txBody>
+      </p:sp>
+      <p:sp>
+        <p:nvSpPr>
+          <p:cNvPr id="10" name="ProjectText">
+            <a:extLst>
+              <a:ext uri="{FF2B5EF4-FFF2-40B4-BE49-F238E27FC236}">
+                <a16:creationId xmlns:a16="http://schemas.microsoft.com/office/drawing/2014/main" id="{AAF0D52F-EA88-7AD3-C4EB-89BE6411C13C}"/>
               </a:ext>
             </a:extLst>
           </p:cNvPr>
@@ -7725,29 +7881,24 @@
             <p:ph type="body" sz="quarter" idx="16"/>
           </p:nvPr>
         </p:nvSpPr>
-        <p:spPr>
-          <a:xfrm>
-            <a:off x="4027990" y="3363097"/>
-            <a:ext cx="7832685" cy="2821330"/>
-          </a:xfrm>
-        </p:spPr>
-        <p:txBody>
-          <a:bodyPr lIns="0" tIns="45720" rIns="91440" bIns="45720" anchor="t"/>
+        <p:spPr/>
+        <p:txBody>
+          <a:bodyPr/>
           <a:lstStyle/>
           <a:p>
             <a:r>
-              <a:rPr lang="en-US">
+              <a:rPr lang="en-US" dirty="0">
                 <a:latin typeface="PT Sans"/>
               </a:rPr>
               <a:t>Conceptualization and Implementation of a skills management tool </a:t>
             </a:r>
             <a:r>
-              <a:rPr lang="de-DE">
+              <a:rPr lang="de-DE" dirty="0">
                 <a:latin typeface="PT Sans"/>
               </a:rPr>
               <a:t> – Software Engineer</a:t>
             </a:r>
-            <a:endParaRPr lang="en-US">
+            <a:endParaRPr lang="en-US" dirty="0">
               <a:latin typeface="PT Sans"/>
             </a:endParaRPr>
           </a:p>
@@ -7757,7 +7908,7 @@
               <a:buChar char="§"/>
             </a:pPr>
             <a:r>
-              <a:rPr lang="en-GB" b="0">
+              <a:rPr lang="en-GB" b="0" dirty="0">
                 <a:latin typeface="PT Sans"/>
               </a:rPr>
               <a:t>Conceptualized a skill management tool to better manage employee's skills, experiences and match those skills and experiences to projects and learning opportunities. Responsible for architecting initial application structure and communication objects.</a:t>
@@ -7769,55 +7920,55 @@
               <a:buChar char="§"/>
             </a:pPr>
             <a:r>
-              <a:rPr lang="en-GB" b="0">
+              <a:rPr lang="en-GB" b="0" dirty="0">
                 <a:latin typeface="PT Sans"/>
               </a:rPr>
               <a:t>Development of backend with </a:t>
             </a:r>
             <a:r>
-              <a:rPr lang="en-GB" b="0" err="1">
+              <a:rPr lang="en-GB" b="0" dirty="0" err="1">
                 <a:latin typeface="PT Sans"/>
               </a:rPr>
               <a:t>NodeJs</a:t>
             </a:r>
             <a:r>
-              <a:rPr lang="en-GB" b="0">
+              <a:rPr lang="en-GB" b="0" dirty="0">
                 <a:latin typeface="PT Sans"/>
               </a:rPr>
               <a:t> and a graph-based database and development of the frontend with Vue framework whilst using </a:t>
             </a:r>
             <a:r>
-              <a:rPr lang="en-GB" b="0" err="1">
+              <a:rPr lang="en-GB" b="0" dirty="0" err="1">
                 <a:latin typeface="PT Sans"/>
               </a:rPr>
               <a:t>OpenAPI</a:t>
             </a:r>
             <a:r>
-              <a:rPr lang="en-GB" b="0">
+              <a:rPr lang="en-GB" b="0" dirty="0">
                 <a:latin typeface="PT Sans"/>
               </a:rPr>
               <a:t> 3.0 standards. Jest (unit tests </a:t>
             </a:r>
             <a:r>
-              <a:rPr lang="en-GB" b="0" err="1">
+              <a:rPr lang="en-GB" b="0" dirty="0" err="1">
                 <a:latin typeface="PT Sans"/>
               </a:rPr>
               <a:t>nodejs</a:t>
             </a:r>
             <a:r>
-              <a:rPr lang="en-GB" b="0">
+              <a:rPr lang="en-GB" b="0" dirty="0">
                 <a:latin typeface="PT Sans"/>
               </a:rPr>
               <a:t>), </a:t>
             </a:r>
             <a:r>
-              <a:rPr lang="en-GB" b="0" err="1">
+              <a:rPr lang="en-GB" b="0" dirty="0" err="1">
                 <a:latin typeface="PT Sans"/>
               </a:rPr>
               <a:t>Vitest</a:t>
             </a:r>
             <a:r>
-              <a:rPr lang="en-GB" b="0">
+              <a:rPr lang="en-GB" b="0" dirty="0">
                 <a:latin typeface="PT Sans"/>
               </a:rPr>
               <a:t> (unit tests frontend) and Cypress (End-to-End) were implemented to avoid unexpected behaviour.</a:t>
@@ -7828,1164 +7979,23 @@
               <a:buChar char="§"/>
             </a:pPr>
             <a:r>
-              <a:rPr lang="en-GB" b="0">
+              <a:rPr lang="en-GB" b="0" dirty="0">
                 <a:latin typeface="PT Sans"/>
               </a:rPr>
               <a:t>Main responsible to create deployment files with a deployment using Docker and Kubernetes on an AWS infrastructure</a:t>
             </a:r>
           </a:p>
           <a:p>
-            <a:r>
-              <a:rPr lang="en-US">
-                <a:latin typeface="PT Sans"/>
-              </a:rPr>
-              <a:t>Development of logistics management application</a:t>
-            </a:r>
-            <a:r>
-              <a:rPr lang="de-DE">
-                <a:latin typeface="PT Sans"/>
-              </a:rPr>
-              <a:t> with multiple </a:t>
-            </a:r>
-            <a:r>
-              <a:rPr lang="de-DE" err="1">
-                <a:latin typeface="PT Sans"/>
-              </a:rPr>
-              <a:t>pluggable</a:t>
-            </a:r>
-            <a:r>
-              <a:rPr lang="de-DE">
-                <a:latin typeface="PT Sans"/>
-              </a:rPr>
-              <a:t> </a:t>
-            </a:r>
-            <a:r>
-              <a:rPr lang="de-DE" err="1">
-                <a:latin typeface="PT Sans"/>
-              </a:rPr>
-              <a:t>modules</a:t>
-            </a:r>
-            <a:r>
-              <a:rPr lang="de-DE">
-                <a:latin typeface="PT Sans"/>
-              </a:rPr>
-              <a:t> – Software Engineer</a:t>
-            </a:r>
-            <a:endParaRPr lang="en-US"/>
-          </a:p>
-          <a:p>
-            <a:pPr marL="171450" indent="-171450">
-              <a:buFont typeface="Wingdings" pitchFamily="2" charset="2"/>
-              <a:buChar char="§"/>
-            </a:pPr>
-            <a:r>
-              <a:rPr lang="en-US" b="0">
-                <a:latin typeface="PT Sans"/>
-              </a:rPr>
-              <a:t>Responsible for the development of cross project generic components in frontend using the Vue framework providing type security with Typescript.</a:t>
-            </a:r>
-            <a:endParaRPr lang="en-US"/>
-          </a:p>
-          <a:p>
-            <a:pPr marL="171450" indent="-171450">
-              <a:buFont typeface="Wingdings" pitchFamily="2" charset="2"/>
-              <a:buChar char="§"/>
-            </a:pPr>
-            <a:r>
-              <a:rPr lang="en-US" b="0">
-                <a:latin typeface="PT Sans"/>
-              </a:rPr>
-              <a:t>Design and implemented a generic query service in java using the hibernate framework that is easily configurable for different use cases and databases.</a:t>
-            </a:r>
-            <a:endParaRPr lang="en-US" b="0"/>
-          </a:p>
-          <a:p>
-            <a:pPr marL="171450" indent="-171450">
-              <a:buFont typeface="Wingdings" pitchFamily="2" charset="2"/>
-              <a:buChar char="§"/>
-            </a:pPr>
-            <a:r>
-              <a:rPr lang="en-US" b="0">
-                <a:latin typeface="PT Sans"/>
-              </a:rPr>
-              <a:t>Extended and maintained deployment files to adapt to new realities or add new modules. On-premise deployment with Docker and Kubernetes</a:t>
-            </a:r>
-            <a:endParaRPr lang="en-US" b="0"/>
-          </a:p>
-          <a:p>
-            <a:pPr marL="171450" indent="-171450">
-              <a:buFont typeface="Wingdings" pitchFamily="2" charset="2"/>
-              <a:buChar char="§"/>
-            </a:pPr>
-            <a:r>
-              <a:rPr lang="en-US" b="0">
-                <a:latin typeface="PT Sans"/>
-              </a:rPr>
-              <a:t>Architected, planned and build an entire module during which he reviewed work from team members,  coordinated with different stakeholders and ensured to write an easily configurable architecture so that the module could be extended, customized and served to different customers.</a:t>
-            </a:r>
-            <a:endParaRPr lang="en-US" b="0"/>
-          </a:p>
-          <a:p>
-            <a:r>
-              <a:rPr lang="en-US">
-                <a:latin typeface="PT Sans"/>
-              </a:rPr>
-              <a:t>Implementation of a note-taking application </a:t>
-            </a:r>
-            <a:r>
-              <a:rPr lang="de-DE">
-                <a:latin typeface="PT Sans"/>
-              </a:rPr>
-              <a:t> – Software Engineer</a:t>
-            </a:r>
-            <a:endParaRPr lang="en-US" b="0"/>
-          </a:p>
-          <a:p>
-            <a:pPr marL="171450" indent="-171450">
-              <a:buFont typeface="Wingdings" pitchFamily="2" charset="2"/>
-              <a:buChar char="§"/>
-            </a:pPr>
-            <a:r>
-              <a:rPr lang="de-DE" b="0">
-                <a:latin typeface="PT Sans"/>
-              </a:rPr>
-              <a:t>Development </a:t>
-            </a:r>
-            <a:r>
-              <a:rPr lang="de-DE" b="0" err="1">
-                <a:latin typeface="PT Sans"/>
-              </a:rPr>
-              <a:t>of</a:t>
-            </a:r>
-            <a:r>
-              <a:rPr lang="de-DE" b="0">
-                <a:latin typeface="PT Sans"/>
-              </a:rPr>
-              <a:t> a </a:t>
-            </a:r>
-            <a:r>
-              <a:rPr lang="de-DE" b="0" err="1">
-                <a:latin typeface="PT Sans"/>
-              </a:rPr>
-              <a:t>cloud-based</a:t>
-            </a:r>
-            <a:r>
-              <a:rPr lang="de-DE" b="0">
-                <a:latin typeface="PT Sans"/>
-              </a:rPr>
-              <a:t> </a:t>
-            </a:r>
-            <a:r>
-              <a:rPr lang="de-DE" b="0" err="1">
-                <a:latin typeface="PT Sans"/>
-              </a:rPr>
-              <a:t>note-taking</a:t>
-            </a:r>
-            <a:r>
-              <a:rPr lang="de-DE" b="0">
-                <a:latin typeface="PT Sans"/>
-              </a:rPr>
-              <a:t> </a:t>
-            </a:r>
-            <a:r>
-              <a:rPr lang="de-DE" b="0" err="1">
-                <a:latin typeface="PT Sans"/>
-              </a:rPr>
-              <a:t>application</a:t>
-            </a:r>
-            <a:r>
-              <a:rPr lang="de-DE" b="0">
-                <a:latin typeface="PT Sans"/>
-              </a:rPr>
-              <a:t> </a:t>
-            </a:r>
-            <a:r>
-              <a:rPr lang="de-DE" b="0" err="1">
-                <a:latin typeface="PT Sans"/>
-              </a:rPr>
-              <a:t>implemented</a:t>
-            </a:r>
-            <a:r>
-              <a:rPr lang="de-DE" b="0">
-                <a:latin typeface="PT Sans"/>
-              </a:rPr>
-              <a:t> </a:t>
-            </a:r>
-            <a:r>
-              <a:rPr lang="de-DE" b="0" err="1">
-                <a:latin typeface="PT Sans"/>
-              </a:rPr>
-              <a:t>according</a:t>
-            </a:r>
-            <a:r>
-              <a:rPr lang="de-DE" b="0">
-                <a:latin typeface="PT Sans"/>
-              </a:rPr>
-              <a:t> to </a:t>
-            </a:r>
-            <a:r>
-              <a:rPr lang="de-DE" b="0" err="1">
-                <a:latin typeface="PT Sans"/>
-              </a:rPr>
-              <a:t>the</a:t>
-            </a:r>
-            <a:r>
-              <a:rPr lang="de-DE" b="0">
-                <a:latin typeface="PT Sans"/>
-              </a:rPr>
-              <a:t> </a:t>
-            </a:r>
-            <a:r>
-              <a:rPr lang="de-DE" b="0" err="1">
-                <a:latin typeface="PT Sans"/>
-              </a:rPr>
-              <a:t>socially</a:t>
-            </a:r>
-            <a:r>
-              <a:rPr lang="de-DE" b="0">
-                <a:latin typeface="PT Sans"/>
-              </a:rPr>
-              <a:t> </a:t>
-            </a:r>
-            <a:r>
-              <a:rPr lang="de-DE" b="0" err="1">
-                <a:latin typeface="PT Sans"/>
-              </a:rPr>
-              <a:t>linked</a:t>
-            </a:r>
-            <a:r>
-              <a:rPr lang="de-DE" b="0">
-                <a:latin typeface="PT Sans"/>
-              </a:rPr>
-              <a:t> </a:t>
-            </a:r>
-            <a:r>
-              <a:rPr lang="de-DE" b="0" err="1">
-                <a:latin typeface="PT Sans"/>
-              </a:rPr>
-              <a:t>specifications</a:t>
-            </a:r>
-            <a:r>
-              <a:rPr lang="de-DE" b="0">
-                <a:latin typeface="PT Sans"/>
-              </a:rPr>
-              <a:t> </a:t>
-            </a:r>
-            <a:r>
-              <a:rPr lang="de-DE" b="0" err="1">
-                <a:latin typeface="PT Sans"/>
-              </a:rPr>
-              <a:t>as</a:t>
-            </a:r>
-            <a:r>
-              <a:rPr lang="de-DE" b="0">
-                <a:latin typeface="PT Sans"/>
-              </a:rPr>
-              <a:t> </a:t>
-            </a:r>
-            <a:r>
-              <a:rPr lang="de-DE" b="0" err="1">
-                <a:latin typeface="PT Sans"/>
-              </a:rPr>
-              <a:t>published</a:t>
-            </a:r>
-            <a:r>
-              <a:rPr lang="de-DE" b="0">
-                <a:latin typeface="PT Sans"/>
-              </a:rPr>
-              <a:t> </a:t>
-            </a:r>
-            <a:r>
-              <a:rPr lang="de-DE" b="0" err="1">
-                <a:latin typeface="PT Sans"/>
-              </a:rPr>
-              <a:t>by</a:t>
-            </a:r>
-            <a:r>
-              <a:rPr lang="de-DE" b="0">
-                <a:latin typeface="PT Sans"/>
-              </a:rPr>
-              <a:t> </a:t>
-            </a:r>
-            <a:r>
-              <a:rPr lang="de-DE" b="0" err="1">
-                <a:latin typeface="PT Sans"/>
-              </a:rPr>
-              <a:t>the</a:t>
-            </a:r>
-            <a:r>
-              <a:rPr lang="de-DE" b="0">
-                <a:latin typeface="PT Sans"/>
-              </a:rPr>
-              <a:t> W3C. </a:t>
-            </a:r>
-            <a:endParaRPr lang="de-DE" b="0"/>
-          </a:p>
-          <a:p>
-            <a:pPr marL="171450" indent="-171450">
-              <a:buChar char="§"/>
-            </a:pPr>
-            <a:r>
-              <a:rPr lang="de-DE" b="0">
-                <a:latin typeface="PT Sans"/>
-              </a:rPr>
-              <a:t>Design </a:t>
-            </a:r>
-            <a:r>
-              <a:rPr lang="de-DE" b="0" err="1">
-                <a:latin typeface="PT Sans"/>
-              </a:rPr>
-              <a:t>of</a:t>
-            </a:r>
-            <a:r>
-              <a:rPr lang="de-DE" b="0">
-                <a:latin typeface="PT Sans"/>
-              </a:rPr>
-              <a:t> a </a:t>
-            </a:r>
-            <a:r>
-              <a:rPr lang="de-DE" b="0" err="1">
-                <a:latin typeface="PT Sans"/>
-              </a:rPr>
-              <a:t>note-taking</a:t>
-            </a:r>
-            <a:r>
-              <a:rPr lang="de-DE" b="0">
-                <a:latin typeface="PT Sans"/>
-              </a:rPr>
-              <a:t> </a:t>
-            </a:r>
-            <a:r>
-              <a:rPr lang="de-DE" b="0" err="1">
-                <a:latin typeface="PT Sans"/>
-              </a:rPr>
-              <a:t>ontology</a:t>
-            </a:r>
-            <a:r>
-              <a:rPr lang="de-DE" b="0">
-                <a:latin typeface="PT Sans"/>
-              </a:rPr>
-              <a:t> </a:t>
-            </a:r>
-            <a:r>
-              <a:rPr lang="de-DE" b="0" err="1">
-                <a:latin typeface="PT Sans"/>
-              </a:rPr>
-              <a:t>to</a:t>
-            </a:r>
-            <a:r>
-              <a:rPr lang="de-DE" b="0">
-                <a:latin typeface="PT Sans"/>
-              </a:rPr>
-              <a:t> </a:t>
-            </a:r>
-            <a:r>
-              <a:rPr lang="de-DE" b="0" err="1">
-                <a:latin typeface="PT Sans"/>
-              </a:rPr>
-              <a:t>ensure</a:t>
-            </a:r>
-            <a:r>
-              <a:rPr lang="de-DE" b="0">
-                <a:latin typeface="PT Sans"/>
-              </a:rPr>
-              <a:t> </a:t>
-            </a:r>
-            <a:r>
-              <a:rPr lang="de-DE" b="0" err="1">
-                <a:latin typeface="PT Sans"/>
-              </a:rPr>
-              <a:t>cross</a:t>
-            </a:r>
-            <a:r>
-              <a:rPr lang="de-DE" b="0">
-                <a:latin typeface="PT Sans"/>
-              </a:rPr>
-              <a:t>-solid-</a:t>
-            </a:r>
-            <a:r>
-              <a:rPr lang="de-DE" b="0" err="1">
-                <a:latin typeface="PT Sans"/>
-              </a:rPr>
-              <a:t>pod</a:t>
-            </a:r>
-            <a:r>
-              <a:rPr lang="de-DE" b="0">
-                <a:latin typeface="PT Sans"/>
-              </a:rPr>
-              <a:t> </a:t>
-            </a:r>
-            <a:r>
-              <a:rPr lang="de-DE" b="0" err="1">
-                <a:latin typeface="PT Sans"/>
-              </a:rPr>
-              <a:t>compatibility</a:t>
-            </a:r>
-            <a:r>
-              <a:rPr lang="de-DE" b="0">
-                <a:latin typeface="PT Sans"/>
-              </a:rPr>
-              <a:t> and </a:t>
-            </a:r>
-            <a:r>
-              <a:rPr lang="de-DE" b="0" err="1">
-                <a:latin typeface="PT Sans"/>
-              </a:rPr>
-              <a:t>stored</a:t>
-            </a:r>
-            <a:r>
-              <a:rPr lang="de-DE" b="0">
-                <a:latin typeface="PT Sans"/>
-              </a:rPr>
-              <a:t> </a:t>
-            </a:r>
-            <a:r>
-              <a:rPr lang="de-DE" b="0" err="1">
-                <a:latin typeface="PT Sans"/>
-              </a:rPr>
-              <a:t>user</a:t>
-            </a:r>
-            <a:r>
-              <a:rPr lang="de-DE" b="0">
-                <a:latin typeface="PT Sans"/>
-              </a:rPr>
-              <a:t> </a:t>
-            </a:r>
-            <a:r>
-              <a:rPr lang="de-DE" b="0" err="1">
-                <a:latin typeface="PT Sans"/>
-              </a:rPr>
-              <a:t>information</a:t>
-            </a:r>
-            <a:r>
-              <a:rPr lang="de-DE" b="0">
-                <a:latin typeface="PT Sans"/>
-              </a:rPr>
-              <a:t> </a:t>
-            </a:r>
-            <a:r>
-              <a:rPr lang="de-DE" b="0" err="1">
-                <a:latin typeface="PT Sans"/>
-              </a:rPr>
-              <a:t>as</a:t>
-            </a:r>
-            <a:r>
-              <a:rPr lang="de-DE" b="0">
-                <a:latin typeface="PT Sans"/>
-              </a:rPr>
-              <a:t> </a:t>
-            </a:r>
-            <a:r>
-              <a:rPr lang="de-DE" b="0" err="1">
-                <a:latin typeface="PT Sans"/>
-              </a:rPr>
-              <a:t>knowledge</a:t>
-            </a:r>
-            <a:r>
-              <a:rPr lang="de-DE" b="0">
-                <a:latin typeface="PT Sans"/>
-              </a:rPr>
-              <a:t> </a:t>
-            </a:r>
-            <a:r>
-              <a:rPr lang="de-DE" b="0" err="1">
-                <a:latin typeface="PT Sans"/>
-              </a:rPr>
-              <a:t>graphs</a:t>
-            </a:r>
-            <a:r>
-              <a:rPr lang="de-DE" b="0">
-                <a:latin typeface="PT Sans"/>
-              </a:rPr>
-              <a:t> in </a:t>
-            </a:r>
-            <a:r>
-              <a:rPr lang="de-DE" b="0" err="1">
-                <a:latin typeface="PT Sans"/>
-              </a:rPr>
-              <a:t>their</a:t>
-            </a:r>
-            <a:r>
-              <a:rPr lang="de-DE" b="0">
-                <a:latin typeface="PT Sans"/>
-              </a:rPr>
-              <a:t> </a:t>
-            </a:r>
-            <a:r>
-              <a:rPr lang="de-DE" b="0" err="1">
-                <a:latin typeface="PT Sans"/>
-              </a:rPr>
-              <a:t>respective</a:t>
-            </a:r>
-            <a:r>
-              <a:rPr lang="de-DE" b="0">
-                <a:latin typeface="PT Sans"/>
-              </a:rPr>
-              <a:t> solid </a:t>
-            </a:r>
-            <a:r>
-              <a:rPr lang="de-DE" b="0" err="1">
-                <a:latin typeface="PT Sans"/>
-              </a:rPr>
-              <a:t>pods</a:t>
-            </a:r>
-            <a:r>
-              <a:rPr lang="de-DE" b="0">
-                <a:latin typeface="PT Sans"/>
-              </a:rPr>
-              <a:t>. </a:t>
-            </a:r>
-            <a:endParaRPr lang="de-DE" b="0"/>
-          </a:p>
-        </p:txBody>
-      </p:sp>
-      <p:sp>
-        <p:nvSpPr>
-          <p:cNvPr id="17" name="phoneText">
-            <a:extLst>
-              <a:ext uri="{FF2B5EF4-FFF2-40B4-BE49-F238E27FC236}">
-                <a16:creationId xmlns:a16="http://schemas.microsoft.com/office/drawing/2014/main" id="{18DB99BF-AA40-984F-B0CB-CCF72B9D4806}"/>
-              </a:ext>
-            </a:extLst>
-          </p:cNvPr>
-          <p:cNvSpPr>
-            <a:spLocks noGrp="1"/>
-          </p:cNvSpPr>
-          <p:nvPr>
-            <p:ph type="body" sz="quarter" idx="23"/>
-          </p:nvPr>
-        </p:nvSpPr>
-        <p:spPr/>
-        <p:txBody>
-          <a:bodyPr lIns="91440" tIns="45720" rIns="91440" bIns="45720" anchor="t"/>
-          <a:lstStyle/>
-          <a:p>
-            <a:r>
-              <a:rPr lang="de-DE" err="1">
-                <a:latin typeface="PT Sans"/>
-              </a:rPr>
-              <a:t>n.a</a:t>
-            </a:r>
-            <a:r>
-              <a:rPr lang="de-DE">
-                <a:latin typeface="PT Sans"/>
-              </a:rPr>
-              <a:t>.</a:t>
-            </a:r>
-          </a:p>
-        </p:txBody>
-      </p:sp>
-      <p:sp>
-        <p:nvSpPr>
-          <p:cNvPr id="18" name="emailText">
-            <a:extLst>
-              <a:ext uri="{FF2B5EF4-FFF2-40B4-BE49-F238E27FC236}">
-                <a16:creationId xmlns:a16="http://schemas.microsoft.com/office/drawing/2014/main" id="{BEE91886-3F12-4140-B909-8B0CE373F58D}"/>
-              </a:ext>
-            </a:extLst>
-          </p:cNvPr>
-          <p:cNvSpPr>
-            <a:spLocks noGrp="1"/>
-          </p:cNvSpPr>
-          <p:nvPr>
-            <p:ph type="body" sz="quarter" idx="24"/>
-          </p:nvPr>
-        </p:nvSpPr>
-        <p:spPr/>
-        <p:txBody>
-          <a:bodyPr lIns="91440" tIns="45720" rIns="91440" bIns="45720" anchor="t"/>
-          <a:lstStyle/>
-          <a:p>
-            <a:r>
-              <a:rPr lang="de-DE" err="1">
-                <a:latin typeface="PT Sans"/>
-              </a:rPr>
-              <a:t>n.a</a:t>
-            </a:r>
-            <a:r>
-              <a:rPr lang="de-DE">
-                <a:latin typeface="PT Sans"/>
-              </a:rPr>
-              <a:t>. </a:t>
-            </a:r>
-            <a:endParaRPr lang="en-DE"/>
-          </a:p>
-        </p:txBody>
-      </p:sp>
-      <p:sp>
-        <p:nvSpPr>
-          <p:cNvPr id="16" name="RoleText">
-            <a:extLst>
-              <a:ext uri="{FF2B5EF4-FFF2-40B4-BE49-F238E27FC236}">
-                <a16:creationId xmlns:a16="http://schemas.microsoft.com/office/drawing/2014/main" id="{C7564505-48C6-A840-812D-73E45184214C}"/>
-              </a:ext>
-            </a:extLst>
-          </p:cNvPr>
-          <p:cNvSpPr>
-            <a:spLocks noGrp="1"/>
-          </p:cNvSpPr>
-          <p:nvPr>
-            <p:ph type="body" sz="quarter" idx="20"/>
-          </p:nvPr>
-        </p:nvSpPr>
-        <p:spPr/>
-        <p:txBody>
-          <a:bodyPr lIns="91440" tIns="45720" rIns="91440" bIns="45720" anchor="t"/>
-          <a:lstStyle/>
-          <a:p>
-            <a:r>
-              <a:rPr lang="de-DE">
-                <a:latin typeface="PT Sans"/>
-              </a:rPr>
-              <a:t>Software Engineer</a:t>
-            </a:r>
-            <a:endParaRPr lang="en-DE">
-              <a:latin typeface="PT Sans"/>
-            </a:endParaRPr>
-          </a:p>
-        </p:txBody>
-      </p:sp>
-      <p:sp>
-        <p:nvSpPr>
-          <p:cNvPr id="15" name="NameText">
-            <a:extLst>
-              <a:ext uri="{FF2B5EF4-FFF2-40B4-BE49-F238E27FC236}">
-                <a16:creationId xmlns:a16="http://schemas.microsoft.com/office/drawing/2014/main" id="{6A336D11-B3C9-8445-A252-C67899FD3680}"/>
-              </a:ext>
-            </a:extLst>
-          </p:cNvPr>
-          <p:cNvSpPr>
-            <a:spLocks noGrp="1"/>
-          </p:cNvSpPr>
-          <p:nvPr>
-            <p:ph type="body" sz="quarter" idx="19"/>
-          </p:nvPr>
-        </p:nvSpPr>
-        <p:spPr/>
-        <p:txBody>
-          <a:bodyPr lIns="91440" tIns="45720" rIns="91440" bIns="45720" anchor="t"/>
-          <a:lstStyle/>
-          <a:p>
-            <a:endParaRPr lang="en-US" b="0">
-              <a:cs typeface="Arial"/>
-            </a:endParaRPr>
-          </a:p>
-        </p:txBody>
-      </p:sp>
-      <p:sp>
-        <p:nvSpPr>
-          <p:cNvPr id="19" name="ProfessionalBackgroundText">
-            <a:extLst>
-              <a:ext uri="{FF2B5EF4-FFF2-40B4-BE49-F238E27FC236}">
-                <a16:creationId xmlns:a16="http://schemas.microsoft.com/office/drawing/2014/main" id="{446AE596-B2E1-D14B-8DAF-0026EE16AB51}"/>
-              </a:ext>
-            </a:extLst>
-          </p:cNvPr>
-          <p:cNvSpPr>
-            <a:spLocks noGrp="1"/>
-          </p:cNvSpPr>
-          <p:nvPr>
-            <p:ph type="body" sz="quarter" idx="25"/>
-          </p:nvPr>
-        </p:nvSpPr>
-        <p:spPr>
-          <a:xfrm>
-            <a:off x="438150" y="3381132"/>
-            <a:ext cx="3286125" cy="2821572"/>
-          </a:xfrm>
-        </p:spPr>
-        <p:txBody>
-          <a:bodyPr lIns="0" tIns="45720" rIns="91440" bIns="45720" anchor="t"/>
-          <a:lstStyle/>
-          <a:p>
-            <a:pPr algn="just"/>
-            <a:r>
-              <a:rPr lang="en-GB">
-                <a:latin typeface="PT Sans"/>
-                <a:cs typeface="Arial"/>
-              </a:rPr>
-              <a:t>He is an experienced software Engineer with several years of experience in java, python and  </a:t>
-            </a:r>
-            <a:r>
-              <a:rPr lang="en-GB" err="1">
-                <a:latin typeface="PT Sans"/>
-                <a:cs typeface="Arial"/>
-              </a:rPr>
-              <a:t>javascript</a:t>
-            </a:r>
-            <a:r>
-              <a:rPr lang="en-GB">
-                <a:latin typeface="PT Sans"/>
-                <a:cs typeface="Arial"/>
-              </a:rPr>
-              <a:t> / typescript.</a:t>
-            </a:r>
-            <a:endParaRPr lang="en-US">
-              <a:latin typeface="PT Sans"/>
-              <a:cs typeface="Arial"/>
-            </a:endParaRPr>
-          </a:p>
-          <a:p>
-            <a:pPr algn="just"/>
-            <a:r>
-              <a:rPr lang="en-GB">
-                <a:latin typeface="PT Sans"/>
-                <a:cs typeface="Arial"/>
-              </a:rPr>
-              <a:t>Over the years, he worked with several teams that applied extensive code reviews, exclusively worked with teams that used Git, wrote git-hooks, performed many Rollbacks, rebases and automated merge-processes wherever possible.</a:t>
-            </a:r>
-          </a:p>
-          <a:p>
-            <a:pPr algn="just"/>
-            <a:r>
-              <a:rPr lang="en-GB">
-                <a:latin typeface="PT Sans"/>
-                <a:cs typeface="Arial"/>
-              </a:rPr>
-              <a:t>In different teams he has worked with several code quality tools/suits (e.g., SonarQube, </a:t>
-            </a:r>
-            <a:r>
-              <a:rPr lang="en-GB" err="1">
-                <a:latin typeface="PT Sans"/>
-                <a:cs typeface="Arial"/>
-              </a:rPr>
-              <a:t>DeepScan</a:t>
-            </a:r>
-            <a:r>
-              <a:rPr lang="en-GB">
-                <a:latin typeface="PT Sans"/>
-                <a:cs typeface="Arial"/>
-              </a:rPr>
-              <a:t>, </a:t>
-            </a:r>
-            <a:r>
-              <a:rPr lang="en-GB" err="1">
-                <a:latin typeface="PT Sans"/>
-                <a:cs typeface="Arial"/>
-              </a:rPr>
-              <a:t>Eslint</a:t>
-            </a:r>
-            <a:r>
-              <a:rPr lang="en-GB">
-                <a:latin typeface="PT Sans"/>
-                <a:cs typeface="Arial"/>
-              </a:rPr>
-              <a:t>), including them in DevOps pipelines using Quality Gates to ensure code quality but also test coverage.</a:t>
-            </a:r>
-          </a:p>
-          <a:p>
-            <a:pPr algn="just"/>
-            <a:r>
-              <a:rPr lang="en-GB">
-                <a:latin typeface="PT Sans"/>
-                <a:cs typeface="Arial"/>
-              </a:rPr>
-              <a:t>Clean code and clean architecture are concepts that he feels very strongly about and tries to implement daily. </a:t>
-            </a:r>
-          </a:p>
-          <a:p>
-            <a:pPr algn="just"/>
-            <a:r>
-              <a:rPr lang="en-GB">
-                <a:latin typeface="PT Sans"/>
-                <a:cs typeface="Arial"/>
-              </a:rPr>
-              <a:t>In his role as a software engineer and a professional coder, he strongly represents the development stakeholder in the planning process using management language to ensure qualitative and flexible software.</a:t>
-            </a:r>
-          </a:p>
-          <a:p>
-            <a:pPr algn="just"/>
-            <a:endParaRPr lang="en-GB">
-              <a:latin typeface="PT Sans"/>
-              <a:cs typeface="Arial"/>
-            </a:endParaRPr>
-          </a:p>
-          <a:p>
-            <a:pPr algn="just"/>
-            <a:endParaRPr lang="en-US">
-              <a:latin typeface="PT Sans"/>
-              <a:cs typeface="Arial"/>
-            </a:endParaRPr>
-          </a:p>
-          <a:p>
-            <a:pPr algn="just"/>
-            <a:endParaRPr lang="en-DE">
-              <a:latin typeface="PT Sans"/>
-              <a:cs typeface="Arial"/>
-            </a:endParaRPr>
-          </a:p>
-        </p:txBody>
-      </p:sp>
-      <p:sp>
-        <p:nvSpPr>
-          <p:cNvPr id="30" name="Text Placeholder 29">
-            <a:extLst>
-              <a:ext uri="{FF2B5EF4-FFF2-40B4-BE49-F238E27FC236}">
-                <a16:creationId xmlns:a16="http://schemas.microsoft.com/office/drawing/2014/main" id="{6353B695-D861-7F42-8935-FD835717737C}"/>
-              </a:ext>
-            </a:extLst>
-          </p:cNvPr>
-          <p:cNvSpPr>
-            <a:spLocks noGrp="1"/>
-          </p:cNvSpPr>
-          <p:nvPr>
-            <p:ph type="body" sz="quarter" idx="26"/>
-          </p:nvPr>
-        </p:nvSpPr>
-        <p:spPr/>
-        <p:txBody>
-          <a:bodyPr/>
-          <a:lstStyle/>
-          <a:p>
-            <a:endParaRPr lang="en-DE"/>
-          </a:p>
-        </p:txBody>
-      </p:sp>
-      <p:sp>
-        <p:nvSpPr>
-          <p:cNvPr id="11" name="FunctionExpertiseText">
-            <a:extLst>
-              <a:ext uri="{FF2B5EF4-FFF2-40B4-BE49-F238E27FC236}">
-                <a16:creationId xmlns:a16="http://schemas.microsoft.com/office/drawing/2014/main" id="{C4BBBD2B-07C4-354B-9BD1-93E0B29CF39F}"/>
-              </a:ext>
-            </a:extLst>
-          </p:cNvPr>
-          <p:cNvSpPr>
-            <a:spLocks noGrp="1"/>
-          </p:cNvSpPr>
-          <p:nvPr>
-            <p:ph type="body" sz="quarter" idx="11"/>
-          </p:nvPr>
-        </p:nvSpPr>
-        <p:spPr>
-          <a:prstGeom prst="rect">
-            <a:avLst/>
-          </a:prstGeom>
-        </p:spPr>
-        <p:txBody>
-          <a:bodyPr lIns="0" tIns="45720" rIns="91440" bIns="45720" anchor="t"/>
-          <a:lstStyle/>
-          <a:p>
-            <a:pPr>
-              <a:spcBef>
-                <a:spcPts val="100"/>
-              </a:spcBef>
-            </a:pPr>
-            <a:r>
-              <a:rPr lang="de-DE">
-                <a:latin typeface="PT Sans"/>
-              </a:rPr>
-              <a:t>Knowledge Graphs (Neo4j, </a:t>
-            </a:r>
-            <a:r>
-              <a:rPr lang="de-DE" err="1">
-                <a:latin typeface="PT Sans"/>
-              </a:rPr>
-              <a:t>Socially</a:t>
-            </a:r>
-            <a:r>
-              <a:rPr lang="de-DE">
-                <a:latin typeface="PT Sans"/>
-              </a:rPr>
-              <a:t> </a:t>
-            </a:r>
-            <a:r>
-              <a:rPr lang="de-DE" err="1">
-                <a:latin typeface="PT Sans"/>
-              </a:rPr>
-              <a:t>Linked</a:t>
-            </a:r>
-            <a:r>
-              <a:rPr lang="de-DE">
-                <a:latin typeface="PT Sans"/>
-              </a:rPr>
-              <a:t> Data, RDF, OWL)</a:t>
-            </a:r>
-            <a:endParaRPr lang="en-US"/>
-          </a:p>
-          <a:p>
-            <a:pPr>
-              <a:spcBef>
-                <a:spcPts val="100"/>
-              </a:spcBef>
-            </a:pPr>
-            <a:r>
-              <a:rPr lang="de-DE">
-                <a:latin typeface="PT Sans"/>
-              </a:rPr>
-              <a:t>Software Engineering (Open API, Java, JavaScript, Python, Rust)</a:t>
-            </a:r>
-          </a:p>
-          <a:p>
-            <a:pPr>
-              <a:spcBef>
-                <a:spcPts val="100"/>
-              </a:spcBef>
-            </a:pPr>
-            <a:r>
-              <a:rPr lang="de-DE" err="1">
-                <a:latin typeface="PT Sans"/>
-              </a:rPr>
-              <a:t>Javascript</a:t>
-            </a:r>
-            <a:r>
-              <a:rPr lang="de-DE">
-                <a:latin typeface="PT Sans"/>
-              </a:rPr>
-              <a:t> (Vue, </a:t>
-            </a:r>
-            <a:r>
-              <a:rPr lang="de-DE" err="1">
-                <a:latin typeface="PT Sans"/>
-              </a:rPr>
-              <a:t>TypeScript</a:t>
-            </a:r>
-            <a:r>
-              <a:rPr lang="de-DE">
-                <a:latin typeface="PT Sans"/>
-              </a:rPr>
-              <a:t>, Angular, PWA, </a:t>
-            </a:r>
-            <a:r>
-              <a:rPr lang="de-DE" err="1">
-                <a:latin typeface="PT Sans"/>
-              </a:rPr>
-              <a:t>NodeJs</a:t>
-            </a:r>
-            <a:r>
-              <a:rPr lang="de-DE">
-                <a:latin typeface="PT Sans"/>
-              </a:rPr>
-              <a:t>, </a:t>
-            </a:r>
-            <a:r>
-              <a:rPr lang="de-DE" err="1">
-                <a:latin typeface="PT Sans"/>
-              </a:rPr>
-              <a:t>React</a:t>
-            </a:r>
-            <a:r>
-              <a:rPr lang="de-DE">
-                <a:latin typeface="PT Sans"/>
-              </a:rPr>
-              <a:t>, </a:t>
-            </a:r>
-            <a:r>
-              <a:rPr lang="de-DE" err="1">
-                <a:latin typeface="PT Sans"/>
-              </a:rPr>
-              <a:t>GraphDB</a:t>
-            </a:r>
-            <a:r>
-              <a:rPr lang="de-DE">
-                <a:latin typeface="PT Sans"/>
-              </a:rPr>
-              <a:t>)</a:t>
-            </a:r>
-          </a:p>
-          <a:p>
-            <a:pPr>
-              <a:spcBef>
-                <a:spcPts val="100"/>
-              </a:spcBef>
-            </a:pPr>
-            <a:r>
-              <a:rPr lang="de-DE">
-                <a:latin typeface="PT Sans"/>
-              </a:rPr>
-              <a:t>Java (Hibernate, JPA, Spring Boot, Spring Security)</a:t>
-            </a:r>
-          </a:p>
-          <a:p>
-            <a:pPr>
-              <a:spcBef>
-                <a:spcPts val="100"/>
-              </a:spcBef>
-            </a:pPr>
-            <a:r>
-              <a:rPr lang="de-DE" err="1">
-                <a:latin typeface="PT Sans"/>
-              </a:rPr>
-              <a:t>DevOps</a:t>
-            </a:r>
-            <a:r>
-              <a:rPr lang="de-DE">
-                <a:latin typeface="PT Sans"/>
-              </a:rPr>
-              <a:t> (</a:t>
-            </a:r>
-            <a:r>
-              <a:rPr lang="de-DE" err="1">
-                <a:latin typeface="PT Sans"/>
-              </a:rPr>
-              <a:t>Git</a:t>
-            </a:r>
-            <a:r>
-              <a:rPr lang="de-DE">
-                <a:latin typeface="PT Sans"/>
-              </a:rPr>
-              <a:t>, </a:t>
-            </a:r>
-            <a:r>
-              <a:rPr lang="de-DE" err="1">
-                <a:latin typeface="PT Sans"/>
-              </a:rPr>
-              <a:t>GitLab</a:t>
-            </a:r>
-            <a:r>
-              <a:rPr lang="de-DE">
-                <a:latin typeface="PT Sans"/>
-              </a:rPr>
-              <a:t>, GitHub, </a:t>
-            </a:r>
-            <a:r>
-              <a:rPr lang="de-DE" err="1">
-                <a:latin typeface="PT Sans"/>
-              </a:rPr>
-              <a:t>Ansible</a:t>
-            </a:r>
-            <a:r>
-              <a:rPr lang="de-DE">
-                <a:latin typeface="PT Sans"/>
-              </a:rPr>
-              <a:t>, </a:t>
-            </a:r>
-            <a:r>
-              <a:rPr lang="de-DE" err="1">
-                <a:latin typeface="PT Sans"/>
-              </a:rPr>
-              <a:t>Kubernetes</a:t>
-            </a:r>
-            <a:r>
-              <a:rPr lang="de-DE">
-                <a:latin typeface="PT Sans"/>
-              </a:rPr>
-              <a:t>, Maven, </a:t>
-            </a:r>
-            <a:r>
-              <a:rPr lang="de-DE" err="1">
-                <a:latin typeface="PT Sans"/>
-              </a:rPr>
-              <a:t>SonarQube</a:t>
-            </a:r>
-            <a:r>
-              <a:rPr lang="de-DE">
-                <a:latin typeface="PT Sans"/>
-              </a:rPr>
-              <a:t>, Docker)</a:t>
-            </a:r>
-          </a:p>
-          <a:p>
-            <a:pPr>
-              <a:spcBef>
-                <a:spcPts val="100"/>
-              </a:spcBef>
-            </a:pPr>
-            <a:r>
-              <a:rPr lang="de-DE">
-                <a:latin typeface="PT Sans"/>
-              </a:rPr>
-              <a:t>Cloud (Azure, AWS, Terraform, Digital Ocean)</a:t>
-            </a:r>
-          </a:p>
-          <a:p>
-            <a:pPr>
-              <a:spcBef>
-                <a:spcPts val="100"/>
-              </a:spcBef>
-            </a:pPr>
-            <a:r>
-              <a:rPr lang="de-DE">
-                <a:latin typeface="PT Sans"/>
-              </a:rPr>
-              <a:t>English (C2 – IELTS) and German (C1 - TELC)</a:t>
-            </a:r>
-          </a:p>
-        </p:txBody>
-      </p:sp>
-      <p:sp>
-        <p:nvSpPr>
-          <p:cNvPr id="13" name="IndustryExpertiseText">
-            <a:extLst>
-              <a:ext uri="{FF2B5EF4-FFF2-40B4-BE49-F238E27FC236}">
-                <a16:creationId xmlns:a16="http://schemas.microsoft.com/office/drawing/2014/main" id="{AFC50E25-7D7B-0E4C-A0B8-80971988B58B}"/>
-              </a:ext>
-            </a:extLst>
-          </p:cNvPr>
-          <p:cNvSpPr>
-            <a:spLocks noGrp="1"/>
-          </p:cNvSpPr>
-          <p:nvPr>
-            <p:ph type="body" sz="quarter" idx="17"/>
-          </p:nvPr>
-        </p:nvSpPr>
-        <p:spPr>
-          <a:prstGeom prst="rect">
-            <a:avLst/>
-          </a:prstGeom>
-        </p:spPr>
-        <p:txBody>
-          <a:bodyPr lIns="0" tIns="45720" rIns="91440" bIns="45720" anchor="t"/>
-          <a:lstStyle/>
-          <a:p>
-            <a:pPr fontAlgn="base">
-              <a:spcBef>
-                <a:spcPts val="100"/>
-              </a:spcBef>
-            </a:pPr>
-            <a:r>
-              <a:rPr lang="en-US">
-                <a:latin typeface="PT Sans"/>
-              </a:rPr>
-              <a:t>Insurance</a:t>
-            </a:r>
-            <a:endParaRPr lang="en-US"/>
-          </a:p>
-          <a:p>
-            <a:pPr>
-              <a:spcBef>
-                <a:spcPts val="100"/>
-              </a:spcBef>
-            </a:pPr>
-            <a:r>
-              <a:rPr lang="en-US">
-                <a:latin typeface="PT Sans"/>
-              </a:rPr>
-              <a:t>Financial Services </a:t>
-            </a:r>
-            <a:endParaRPr lang="en-US"/>
-          </a:p>
-          <a:p>
-            <a:pPr>
-              <a:spcBef>
-                <a:spcPts val="100"/>
-              </a:spcBef>
-            </a:pPr>
-            <a:r>
-              <a:rPr lang="en-US">
-                <a:latin typeface="PT Sans"/>
-              </a:rPr>
-              <a:t>Human Resources</a:t>
-            </a:r>
-            <a:endParaRPr lang="en-US"/>
-          </a:p>
-          <a:p>
-            <a:pPr marL="0" indent="0" fontAlgn="base">
-              <a:spcBef>
-                <a:spcPts val="100"/>
-              </a:spcBef>
-              <a:buNone/>
-            </a:pPr>
-            <a:endParaRPr lang="de-DE"/>
+            <a:endParaRPr lang="de-DE" dirty="0"/>
           </a:p>
         </p:txBody>
       </p:sp>
       <p:pic>
         <p:nvPicPr>
-          <p:cNvPr id="4" name="ProfilePicture">
-            <a:extLst>
-              <a:ext uri="{FF2B5EF4-FFF2-40B4-BE49-F238E27FC236}">
-                <a16:creationId xmlns:a16="http://schemas.microsoft.com/office/drawing/2014/main" id="{EDC0E935-7D1C-12F6-6A9E-F6315BFE17FC}"/>
+          <p:cNvPr id="13" name="ProfilePicture">
+            <a:extLst>
+              <a:ext uri="{FF2B5EF4-FFF2-40B4-BE49-F238E27FC236}">
+                <a16:creationId xmlns:a16="http://schemas.microsoft.com/office/drawing/2014/main" id="{F379A71B-F7E8-2C99-586A-36ED91F91A4F}"/>
               </a:ext>
             </a:extLst>
           </p:cNvPr>
@@ -8996,9 +8006,15 @@
             <p:ph type="pic" sz="quarter" idx="18"/>
           </p:nvPr>
         </p:nvPicPr>
-        <p:blipFill rotWithShape="1">
-          <a:blip r:embed="rId3"/>
-          <a:srcRect t="316" b="316"/>
+        <p:blipFill>
+          <a:blip r:embed="rId2">
+            <a:extLst>
+              <a:ext uri="{28A0092B-C50C-407E-A947-70E740481C1C}">
+                <a14:useLocalDpi xmlns:a14="http://schemas.microsoft.com/office/drawing/2010/main" val="0"/>
+              </a:ext>
+            </a:extLst>
+          </a:blip>
+          <a:srcRect l="203" r="203"/>
           <a:stretch/>
         </p:blipFill>
         <p:spPr/>
@@ -9006,7 +8022,433 @@
     </p:spTree>
     <p:extLst>
       <p:ext uri="{BB962C8B-B14F-4D97-AF65-F5344CB8AC3E}">
-        <p14:creationId xmlns:p14="http://schemas.microsoft.com/office/powerpoint/2010/main" val="1720935980"/>
+        <p14:creationId xmlns:p14="http://schemas.microsoft.com/office/powerpoint/2010/main" val="1791885592"/>
+      </p:ext>
+    </p:extLst>
+  </p:cSld>
+  <p:clrMapOvr>
+    <a:masterClrMapping/>
+  </p:clrMapOvr>
+</p:sld>
+</file>
+
+<file path=ppt/slides/slide2.xml><?xml version="1.0" encoding="utf-8"?>
+<p:sld xmlns:a="http://schemas.openxmlformats.org/drawingml/2006/main" xmlns:r="http://schemas.openxmlformats.org/officeDocument/2006/relationships" xmlns:p="http://schemas.openxmlformats.org/presentationml/2006/main">
+  <p:cSld>
+    <p:spTree>
+      <p:nvGrpSpPr>
+        <p:cNvPr id="1" name=""/>
+        <p:cNvGrpSpPr/>
+        <p:nvPr/>
+      </p:nvGrpSpPr>
+      <p:grpSpPr>
+        <a:xfrm>
+          <a:off x="0" y="0"/>
+          <a:ext cx="0" cy="0"/>
+          <a:chOff x="0" y="0"/>
+          <a:chExt cx="0" cy="0"/>
+        </a:xfrm>
+      </p:grpSpPr>
+      <p:sp>
+        <p:nvSpPr>
+          <p:cNvPr id="2" name="NameText">
+            <a:extLst>
+              <a:ext uri="{FF2B5EF4-FFF2-40B4-BE49-F238E27FC236}">
+                <a16:creationId xmlns:a16="http://schemas.microsoft.com/office/drawing/2014/main" id="{66C957C3-CA77-A474-D09B-DD4DE78AD1FC}"/>
+              </a:ext>
+            </a:extLst>
+          </p:cNvPr>
+          <p:cNvSpPr>
+            <a:spLocks noGrp="1"/>
+          </p:cNvSpPr>
+          <p:nvPr>
+            <p:ph type="body" sz="quarter" idx="19"/>
+          </p:nvPr>
+        </p:nvSpPr>
+        <p:spPr/>
+        <p:txBody>
+          <a:bodyPr/>
+          <a:lstStyle/>
+          <a:p>
+            <a:r>
+              <a:rPr lang="de-DE" dirty="0"/>
+              <a:t>Maurits</a:t>
+            </a:r>
+          </a:p>
+        </p:txBody>
+      </p:sp>
+      <p:sp>
+        <p:nvSpPr>
+          <p:cNvPr id="3" name="RoleText">
+            <a:extLst>
+              <a:ext uri="{FF2B5EF4-FFF2-40B4-BE49-F238E27FC236}">
+                <a16:creationId xmlns:a16="http://schemas.microsoft.com/office/drawing/2014/main" id="{6D7FAF61-2AC8-6E83-F0D3-319566BDAA24}"/>
+              </a:ext>
+            </a:extLst>
+          </p:cNvPr>
+          <p:cNvSpPr>
+            <a:spLocks noGrp="1"/>
+          </p:cNvSpPr>
+          <p:nvPr>
+            <p:ph type="body" sz="quarter" idx="20"/>
+          </p:nvPr>
+        </p:nvSpPr>
+        <p:spPr/>
+        <p:txBody>
+          <a:bodyPr/>
+          <a:lstStyle/>
+          <a:p>
+            <a:r>
+              <a:rPr lang="de-DE" dirty="0"/>
+              <a:t>Positio</a:t>
+            </a:r>
+          </a:p>
+        </p:txBody>
+      </p:sp>
+      <p:sp>
+        <p:nvSpPr>
+          <p:cNvPr id="4" name="phoneText">
+            <a:extLst>
+              <a:ext uri="{FF2B5EF4-FFF2-40B4-BE49-F238E27FC236}">
+                <a16:creationId xmlns:a16="http://schemas.microsoft.com/office/drawing/2014/main" id="{AD1E31AD-E4A6-3E34-9479-DA8749389BCD}"/>
+              </a:ext>
+            </a:extLst>
+          </p:cNvPr>
+          <p:cNvSpPr>
+            <a:spLocks noGrp="1"/>
+          </p:cNvSpPr>
+          <p:nvPr>
+            <p:ph type="body" sz="quarter" idx="23"/>
+          </p:nvPr>
+        </p:nvSpPr>
+        <p:spPr/>
+        <p:txBody>
+          <a:bodyPr/>
+          <a:lstStyle/>
+          <a:p>
+            <a:r>
+              <a:rPr lang="de-DE" dirty="0"/>
+              <a:t>na</a:t>
+            </a:r>
+          </a:p>
+        </p:txBody>
+      </p:sp>
+      <p:sp>
+        <p:nvSpPr>
+          <p:cNvPr id="5" name="emailText">
+            <a:extLst>
+              <a:ext uri="{FF2B5EF4-FFF2-40B4-BE49-F238E27FC236}">
+                <a16:creationId xmlns:a16="http://schemas.microsoft.com/office/drawing/2014/main" id="{9FB2B923-379A-12E1-2173-F84EB7B78CEB}"/>
+              </a:ext>
+            </a:extLst>
+          </p:cNvPr>
+          <p:cNvSpPr>
+            <a:spLocks noGrp="1"/>
+          </p:cNvSpPr>
+          <p:nvPr>
+            <p:ph type="body" sz="quarter" idx="24"/>
+          </p:nvPr>
+        </p:nvSpPr>
+        <p:spPr/>
+        <p:txBody>
+          <a:bodyPr/>
+          <a:lstStyle/>
+          <a:p>
+            <a:r>
+              <a:rPr lang="de-DE" dirty="0"/>
+              <a:t>na</a:t>
+            </a:r>
+          </a:p>
+        </p:txBody>
+      </p:sp>
+      <p:sp>
+        <p:nvSpPr>
+          <p:cNvPr id="6" name="Text Placeholder 5">
+            <a:extLst>
+              <a:ext uri="{FF2B5EF4-FFF2-40B4-BE49-F238E27FC236}">
+                <a16:creationId xmlns:a16="http://schemas.microsoft.com/office/drawing/2014/main" id="{84F0B364-DF75-C4CC-867F-2985D6C4B8A6}"/>
+              </a:ext>
+            </a:extLst>
+          </p:cNvPr>
+          <p:cNvSpPr>
+            <a:spLocks noGrp="1"/>
+          </p:cNvSpPr>
+          <p:nvPr>
+            <p:ph type="body" sz="quarter" idx="26"/>
+          </p:nvPr>
+        </p:nvSpPr>
+        <p:spPr/>
+        <p:txBody>
+          <a:bodyPr/>
+          <a:lstStyle/>
+          <a:p>
+            <a:endParaRPr lang="de-DE"/>
+          </a:p>
+        </p:txBody>
+      </p:sp>
+      <p:sp>
+        <p:nvSpPr>
+          <p:cNvPr id="7" name="ProfessionalBackgroundText">
+            <a:extLst>
+              <a:ext uri="{FF2B5EF4-FFF2-40B4-BE49-F238E27FC236}">
+                <a16:creationId xmlns:a16="http://schemas.microsoft.com/office/drawing/2014/main" id="{00D52F02-72DD-E618-2907-E03B18DD36BC}"/>
+              </a:ext>
+            </a:extLst>
+          </p:cNvPr>
+          <p:cNvSpPr>
+            <a:spLocks noGrp="1"/>
+          </p:cNvSpPr>
+          <p:nvPr>
+            <p:ph type="body" sz="quarter" idx="25"/>
+          </p:nvPr>
+        </p:nvSpPr>
+        <p:spPr/>
+        <p:txBody>
+          <a:bodyPr/>
+          <a:lstStyle/>
+          <a:p>
+            <a:r>
+              <a:rPr lang="de-DE" dirty="0"/>
+              <a:t>SomeText</a:t>
+            </a:r>
+          </a:p>
+        </p:txBody>
+      </p:sp>
+      <p:sp>
+        <p:nvSpPr>
+          <p:cNvPr id="8" name="IndustryExpertiseText">
+            <a:extLst>
+              <a:ext uri="{FF2B5EF4-FFF2-40B4-BE49-F238E27FC236}">
+                <a16:creationId xmlns:a16="http://schemas.microsoft.com/office/drawing/2014/main" id="{74A9124E-A5D2-DCD8-8982-7830F8FB45A1}"/>
+              </a:ext>
+            </a:extLst>
+          </p:cNvPr>
+          <p:cNvSpPr>
+            <a:spLocks noGrp="1"/>
+          </p:cNvSpPr>
+          <p:nvPr>
+            <p:ph type="body" sz="quarter" idx="17"/>
+          </p:nvPr>
+        </p:nvSpPr>
+        <p:spPr/>
+        <p:txBody>
+          <a:bodyPr/>
+          <a:lstStyle/>
+          <a:p>
+            <a:r>
+              <a:rPr lang="de-DE" dirty="0"/>
+              <a:t>Knowledge Graphs (Neo4j, Socially Linked Data, RDF, OWL)</a:t>
+            </a:r>
+          </a:p>
+          <a:p>
+            <a:r>
+              <a:rPr lang="de-DE" dirty="0"/>
+              <a:t>Software Engineering (Open API, Java, JavaScript, Python, Rust)</a:t>
+            </a:r>
+          </a:p>
+          <a:p>
+            <a:endParaRPr lang="de-DE" dirty="0"/>
+          </a:p>
+        </p:txBody>
+      </p:sp>
+      <p:sp>
+        <p:nvSpPr>
+          <p:cNvPr id="9" name="FunctionExpertiseText">
+            <a:extLst>
+              <a:ext uri="{FF2B5EF4-FFF2-40B4-BE49-F238E27FC236}">
+                <a16:creationId xmlns:a16="http://schemas.microsoft.com/office/drawing/2014/main" id="{7372289E-21EE-3F8F-B147-C65296B5F8C2}"/>
+              </a:ext>
+            </a:extLst>
+          </p:cNvPr>
+          <p:cNvSpPr>
+            <a:spLocks noGrp="1"/>
+          </p:cNvSpPr>
+          <p:nvPr>
+            <p:ph type="body" sz="quarter" idx="11"/>
+          </p:nvPr>
+        </p:nvSpPr>
+        <p:spPr/>
+        <p:txBody>
+          <a:bodyPr/>
+          <a:lstStyle/>
+          <a:p>
+            <a:r>
+              <a:rPr lang="de-DE" dirty="0"/>
+              <a:t>Knowledge Graphs (Neo4j, Socially Linked Data, RDF, OWL)</a:t>
+            </a:r>
+          </a:p>
+          <a:p>
+            <a:r>
+              <a:rPr lang="de-DE" dirty="0"/>
+              <a:t>Software Engineering (Open API, Java, JavaScript, Python, Rust)</a:t>
+            </a:r>
+          </a:p>
+          <a:p>
+            <a:pPr marL="0" indent="0">
+              <a:buNone/>
+            </a:pPr>
+            <a:endParaRPr lang="de-DE" dirty="0"/>
+          </a:p>
+        </p:txBody>
+      </p:sp>
+      <p:sp>
+        <p:nvSpPr>
+          <p:cNvPr id="10" name="ProjectText">
+            <a:extLst>
+              <a:ext uri="{FF2B5EF4-FFF2-40B4-BE49-F238E27FC236}">
+                <a16:creationId xmlns:a16="http://schemas.microsoft.com/office/drawing/2014/main" id="{C3807C9A-D97E-7553-14C3-1601E017F35E}"/>
+              </a:ext>
+            </a:extLst>
+          </p:cNvPr>
+          <p:cNvSpPr>
+            <a:spLocks noGrp="1"/>
+          </p:cNvSpPr>
+          <p:nvPr>
+            <p:ph type="body" sz="quarter" idx="16"/>
+          </p:nvPr>
+        </p:nvSpPr>
+        <p:spPr/>
+        <p:txBody>
+          <a:bodyPr/>
+          <a:lstStyle/>
+          <a:p>
+            <a:r>
+              <a:rPr lang="en-US" dirty="0">
+                <a:latin typeface="PT Sans"/>
+              </a:rPr>
+              <a:t>Conceptualization and Implementation of a skills management tool </a:t>
+            </a:r>
+            <a:r>
+              <a:rPr lang="de-DE" dirty="0">
+                <a:latin typeface="PT Sans"/>
+              </a:rPr>
+              <a:t> – Software Engineer</a:t>
+            </a:r>
+            <a:endParaRPr lang="en-US" dirty="0">
+              <a:latin typeface="PT Sans"/>
+            </a:endParaRPr>
+          </a:p>
+          <a:p>
+            <a:pPr marL="171450" indent="-171450">
+              <a:buFont typeface="Wingdings" pitchFamily="2" charset="2"/>
+              <a:buChar char="§"/>
+            </a:pPr>
+            <a:r>
+              <a:rPr lang="en-GB" b="0" dirty="0">
+                <a:latin typeface="PT Sans"/>
+              </a:rPr>
+              <a:t>Conceptualized a skill management tool to better manage employee's skills, experiences and match those skills and experiences to projects and learning opportunities. Responsible for architecting initial application structure and communication objects.</a:t>
+            </a:r>
+          </a:p>
+          <a:p>
+            <a:pPr marL="171450" indent="-171450">
+              <a:buFont typeface="Wingdings" pitchFamily="2" charset="2"/>
+              <a:buChar char="§"/>
+            </a:pPr>
+            <a:r>
+              <a:rPr lang="en-GB" b="0" dirty="0">
+                <a:latin typeface="PT Sans"/>
+              </a:rPr>
+              <a:t>Development of backend with </a:t>
+            </a:r>
+            <a:r>
+              <a:rPr lang="en-GB" b="0" dirty="0" err="1">
+                <a:latin typeface="PT Sans"/>
+              </a:rPr>
+              <a:t>NodeJs</a:t>
+            </a:r>
+            <a:r>
+              <a:rPr lang="en-GB" b="0" dirty="0">
+                <a:latin typeface="PT Sans"/>
+              </a:rPr>
+              <a:t> and a graph-based database and development of the frontend with Vue framework whilst using </a:t>
+            </a:r>
+            <a:r>
+              <a:rPr lang="en-GB" b="0" dirty="0" err="1">
+                <a:latin typeface="PT Sans"/>
+              </a:rPr>
+              <a:t>OpenAPI</a:t>
+            </a:r>
+            <a:r>
+              <a:rPr lang="en-GB" b="0" dirty="0">
+                <a:latin typeface="PT Sans"/>
+              </a:rPr>
+              <a:t> 3.0 standards. Jest (unit tests </a:t>
+            </a:r>
+            <a:r>
+              <a:rPr lang="en-GB" b="0" dirty="0" err="1">
+                <a:latin typeface="PT Sans"/>
+              </a:rPr>
+              <a:t>nodejs</a:t>
+            </a:r>
+            <a:r>
+              <a:rPr lang="en-GB" b="0" dirty="0">
+                <a:latin typeface="PT Sans"/>
+              </a:rPr>
+              <a:t>), </a:t>
+            </a:r>
+            <a:r>
+              <a:rPr lang="en-GB" b="0" dirty="0" err="1">
+                <a:latin typeface="PT Sans"/>
+              </a:rPr>
+              <a:t>Vitest</a:t>
+            </a:r>
+            <a:r>
+              <a:rPr lang="en-GB" b="0" dirty="0">
+                <a:latin typeface="PT Sans"/>
+              </a:rPr>
+              <a:t> (unit tests frontend) and Cypress (End-to-End) were implemented to avoid unexpected behaviour.</a:t>
+            </a:r>
+          </a:p>
+          <a:p>
+            <a:pPr marL="171450" indent="-171450">
+              <a:buChar char="§"/>
+            </a:pPr>
+            <a:r>
+              <a:rPr lang="en-GB" b="0" dirty="0">
+                <a:latin typeface="PT Sans"/>
+              </a:rPr>
+              <a:t>Main responsible to create deployment files with a deployment using Docker and Kubernetes on an AWS infrastructure</a:t>
+            </a:r>
+          </a:p>
+          <a:p>
+            <a:endParaRPr lang="de-DE" dirty="0"/>
+          </a:p>
+        </p:txBody>
+      </p:sp>
+      <p:pic>
+        <p:nvPicPr>
+          <p:cNvPr id="13" name="ProfilePicture">
+            <a:extLst>
+              <a:ext uri="{FF2B5EF4-FFF2-40B4-BE49-F238E27FC236}">
+                <a16:creationId xmlns:a16="http://schemas.microsoft.com/office/drawing/2014/main" id="{6DFCF047-1430-84A0-FEE6-A7B8D7FF638C}"/>
+              </a:ext>
+            </a:extLst>
+          </p:cNvPr>
+          <p:cNvPicPr>
+            <a:picLocks noGrp="1" noChangeAspect="1"/>
+          </p:cNvPicPr>
+          <p:nvPr>
+            <p:ph type="pic" sz="quarter" idx="18"/>
+          </p:nvPr>
+        </p:nvPicPr>
+        <p:blipFill>
+          <a:blip r:embed="rId2">
+            <a:extLst>
+              <a:ext uri="{28A0092B-C50C-407E-A947-70E740481C1C}">
+                <a14:useLocalDpi xmlns:a14="http://schemas.microsoft.com/office/drawing/2010/main" val="0"/>
+              </a:ext>
+            </a:extLst>
+          </a:blip>
+          <a:srcRect l="203" r="203"/>
+          <a:stretch/>
+        </p:blipFill>
+        <p:spPr/>
+      </p:pic>
+    </p:spTree>
+    <p:extLst>
+      <p:ext uri="{BB962C8B-B14F-4D97-AF65-F5344CB8AC3E}">
+        <p14:creationId xmlns:p14="http://schemas.microsoft.com/office/powerpoint/2010/main" val="988725238"/>
       </p:ext>
     </p:extLst>
   </p:cSld>

</xml_diff>